<commit_message>
Soften the welcome line and regenerate the board video with the Piper voice
Replace "not sure what day it is" with a kinder line in the script, slides
and pitch deck, re-narrate with Piper en_US-lessac-high, rebuild the MP4,
and update runtimes and the audio setup notes in the READMEs.

Co-Authored-By: Claude Fable 5.1 <noreply@anthropic.com>
</commit_message>
<xml_diff>
--- a/docs/pitch/own-board-pitch.pptx
+++ b/docs/pitch/own-board-pitch.pptx
@@ -121,13 +121,13 @@
   <p:extLst>
     <p:ext uri="{521415D9-36F7-43E2-AB2F-B90AF26B5E84}">
       <p14:sectionLst xmlns:p14="http://schemas.microsoft.com/office/powerpoint/2010/main">
-        <p14:section name="Welcome" id="{ffa6e284-23a1-a0c6-e389-9ac0ee0233ab}">
+        <p14:section name="Welcome" id="{f6e6e750-bd45-f50c-1241-9fe655e71877}">
           <p14:sldIdLst>
             <p14:sldId id="256"/>
             <p14:sldId id="257"/>
           </p14:sldIdLst>
         </p14:section>
-        <p14:section name="Six things that matter" id="{b48c0211-f3ed-1d57-7794-2df18c59e5d7}">
+        <p14:section name="Six things that matter" id="{d2c15f81-2926-80d7-2212-92792325f3c0}">
           <p14:sldIdLst>
             <p14:sldId id="258"/>
             <p14:sldId id="259"/>
@@ -141,12 +141,12 @@
             <p14:sldId id="267"/>
           </p14:sldIdLst>
         </p14:section>
-        <p14:section name="Today and next" id="{81a92a26-1a44-2368-4f36-1c1716f9b190}">
+        <p14:section name="Today and next" id="{371896b8-e354-47d3-f500-5b7a1afb9312}">
           <p14:sldIdLst>
             <p14:sldId id="268"/>
           </p14:sldIdLst>
         </p14:section>
-        <p14:section name="Our ask" id="{a2679e6c-e49f-e024-41f4-cb17642fb2d8}">
+        <p14:section name="Our ask" id="{c1d6f784-1050-7b97-3d90-4bba7f5db999}">
           <p14:sldIdLst>
             <p14:sldId id="269"/>
             <p14:sldId id="270"/>
@@ -1172,7 +1172,7 @@
           <a:p>
             <a:r>
               <a:rPr lang="en-US" dirty="0"/>
-              <a:t>Some of us love the internet. Some of us are not sure what day it is, and that is perfectly fine. This platform is for everyone. It is a website, and it is also a helping hand.</a:t>
+              <a:t>Some of us love the internet. Some of us would rather keep things simple, and that is perfectly fine. This platform is for everyone. It is a website, and it is also a helping hand.</a:t>
             </a:r>
             <a:endParaRPr lang="en-US" dirty="0"/>
           </a:p>
@@ -4526,7 +4526,7 @@
                   <a:schemeClr val="tx2"/>
                 </a:solidFill>
               </a:rPr>
-              <a:t>Some of us are not so sure. That is fine.</a:t>
+              <a:t>Some of us like it simple. That is fine.</a:t>
             </a:r>
             <a:endParaRPr lang="en-US" sz="1800" dirty="0"/>
           </a:p>

</xml_diff>